<commit_message>
Submission v2: designed infographic panels inside the official SIH template
</commit_message>
<xml_diff>
--- a/docs/SatQuery_AI_SIH_26167_SUBMISSION.pptx
+++ b/docs/SatQuery_AI_SIH_26167_SUBMISSION.pptx
@@ -5989,109 +5989,7 @@
             </a:endParaRPr>
           </a:p>
           <a:p>
-            <a:pPr marL="342900" indent="-342900" algn="just">
-              <a:buFont typeface="Arial" panose="020B0604020202020204" pitchFamily="34" charset="0"/>
-              <a:buChar char="•"/>
-            </a:pPr>
-            <a:r>
-              <a:rPr lang="en-US" sz="1300" b="1" dirty="0">
-                <a:solidFill>
-                  <a:srgbClr val="1F4E79"/>
-                </a:solidFill>
-                <a:latin typeface="Arial" pitchFamily="34" charset="0"/>
-                <a:cs typeface="Arial" pitchFamily="34" charset="0"/>
-              </a:rPr>
-              <a:t>What it is: </a:t>
-            </a:r>
-            <a:r>
-              <a:rPr lang="en-US" sz="1300" dirty="0">
-                <a:latin typeface="Arial" pitchFamily="34" charset="0"/>
-                <a:cs typeface="Arial" pitchFamily="34" charset="0"/>
-              </a:rPr>
-              <a:t>An agentic vision-language assistant: upload GeoTIFF imagery, ask in natural language, get an evidence-grounded answer (masks/boxes + confidence + auditable trace).</a:t>
-            </a:r>
-          </a:p>
-          <a:p>
-            <a:pPr marL="342900" indent="-342900" algn="just">
-              <a:buFont typeface="Arial" panose="020B0604020202020204" pitchFamily="34" charset="0"/>
-              <a:buChar char="•"/>
-            </a:pPr>
-            <a:r>
-              <a:rPr lang="en-US" sz="1300" dirty="0">
-                <a:latin typeface="Arial" pitchFamily="34" charset="0"/>
-                <a:cs typeface="Arial" pitchFamily="34" charset="0"/>
-              </a:rPr>
-              <a:t>Supports all 3 prescribed inputs — single optical/SAR image, co-registered optical–SAR pair, bi-temporal pair — across VQA, captioning, grounding, change-VQA and fusion.</a:t>
-            </a:r>
-          </a:p>
-          <a:p>
-            <a:pPr marL="342900" indent="-342900" algn="just">
-              <a:buFont typeface="Arial" panose="020B0604020202020204" pitchFamily="34" charset="0"/>
-              <a:buChar char="•"/>
-            </a:pPr>
-            <a:r>
-              <a:rPr lang="en-US" sz="1300" b="1" dirty="0">
-                <a:solidFill>
-                  <a:srgbClr val="1F4E79"/>
-                </a:solidFill>
-                <a:latin typeface="Arial" pitchFamily="34" charset="0"/>
-                <a:cs typeface="Arial" pitchFamily="34" charset="0"/>
-              </a:rPr>
-              <a:t>How it addresses the problem: </a:t>
-            </a:r>
-            <a:r>
-              <a:rPr lang="en-US" sz="1300" dirty="0">
-                <a:latin typeface="Arial" pitchFamily="34" charset="0"/>
-                <a:cs typeface="Arial" pitchFamily="34" charset="0"/>
-              </a:rPr>
-              <a:t>Replaces fragmented single-task RS tools; a controller validates inputs and routes each query to fine-tuned specialist models — no GIS expertise needed.</a:t>
-            </a:r>
-          </a:p>
-          <a:p>
-            <a:pPr marL="342900" indent="-342900" algn="just">
-              <a:buFont typeface="Arial" panose="020B0604020202020204" pitchFamily="34" charset="0"/>
-              <a:buChar char="•"/>
-            </a:pPr>
-            <a:r>
-              <a:rPr lang="en-US" sz="1300" b="1" dirty="0">
-                <a:solidFill>
-                  <a:srgbClr val="1F4E79"/>
-                </a:solidFill>
-                <a:latin typeface="Arial" pitchFamily="34" charset="0"/>
-                <a:cs typeface="Arial" pitchFamily="34" charset="0"/>
-              </a:rPr>
-              <a:t>Innovation &amp; uniqueness: </a:t>
-            </a:r>
-            <a:r>
-              <a:rPr lang="en-US" sz="1300" dirty="0">
-                <a:latin typeface="Arial" pitchFamily="34" charset="0"/>
-                <a:cs typeface="Arial" pitchFamily="34" charset="0"/>
-              </a:rPr>
-              <a:t>Agentic orchestration (not one generic VLM); LoRA adaptation on BigEarthNet.txt — 464,044 co-registered S1 SAR + S2 pairs, 9.6M annotations; rejects incompatible inputs; ships visual evidence + execution summary.</a:t>
-            </a:r>
-          </a:p>
-          <a:p>
-            <a:pPr marL="342900" indent="-342900" algn="just">
-              <a:buFont typeface="Arial" panose="020B0604020202020204" pitchFamily="34" charset="0"/>
-              <a:buChar char="•"/>
-            </a:pPr>
-            <a:r>
-              <a:rPr lang="en-US" sz="1300" b="1" dirty="0">
-                <a:solidFill>
-                  <a:srgbClr val="C00000"/>
-                </a:solidFill>
-                <a:latin typeface="Arial" pitchFamily="34" charset="0"/>
-                <a:cs typeface="Arial" pitchFamily="34" charset="0"/>
-              </a:rPr>
-              <a:t>LIVE: </a:t>
-            </a:r>
-            <a:r>
-              <a:rPr lang="en-US" sz="1300" dirty="0">
-                <a:latin typeface="Arial" pitchFamily="34" charset="0"/>
-                <a:cs typeface="Arial" pitchFamily="34" charset="0"/>
-              </a:rPr>
-              <a:t>Working prototype already deployed — gangadhar017.github.io/Lunar_circle (scan QR →)</a:t>
-            </a:r>
+            <a:endParaRPr lang="en-US"/>
           </a:p>
         </p:txBody>
       </p:sp>
@@ -6249,7 +6147,7 @@
       </p:pic>
       <p:pic>
         <p:nvPicPr>
-          <p:cNvPr id="15363" name="Live console"/>
+          <p:cNvPr id="15363" name="Idea panel"/>
           <p:cNvPicPr>
             <a:picLocks noChangeAspect="1"/>
           </p:cNvPicPr>
@@ -6263,46 +6161,12 @@
         </p:blipFill>
         <p:spPr>
           <a:xfrm>
-            <a:off x="7360920" y="5193792"/>
-            <a:ext cx="2011680" cy="1271016"/>
+            <a:off x="1078992" y="2834640"/>
+            <a:ext cx="10012680" cy="3447288"/>
           </a:xfrm>
           <a:prstGeom prst="rect">
             <a:avLst/>
           </a:prstGeom>
-          <a:ln w="9525">
-            <a:solidFill>
-              <a:srgbClr val="1F4E79"/>
-            </a:solidFill>
-          </a:ln>
-        </p:spPr>
-      </p:pic>
-      <p:pic>
-        <p:nvPicPr>
-          <p:cNvPr id="15364" name="Demo QR"/>
-          <p:cNvPicPr>
-            <a:picLocks noChangeAspect="1"/>
-          </p:cNvPicPr>
-          <p:nvPr/>
-        </p:nvPicPr>
-        <p:blipFill>
-          <a:blip r:embed="rId5"/>
-          <a:stretch>
-            <a:fillRect/>
-          </a:stretch>
-        </p:blipFill>
-        <p:spPr>
-          <a:xfrm>
-            <a:off x="9646920" y="5193792"/>
-            <a:ext cx="1271016" cy="1271016"/>
-          </a:xfrm>
-          <a:prstGeom prst="rect">
-            <a:avLst/>
-          </a:prstGeom>
-          <a:ln w="9525">
-            <a:solidFill>
-              <a:srgbClr val="1F4E79"/>
-            </a:solidFill>
-          </a:ln>
         </p:spPr>
       </p:pic>
     </p:spTree>
@@ -6451,50 +6315,7 @@
           </a:bodyPr>
           <a:lstStyle/>
           <a:p>
-            <a:pPr marL="342900" indent="-342900" algn="just">
-              <a:buFont typeface="Arial" panose="020B0604020202020204" pitchFamily="34" charset="0"/>
-              <a:buChar char="•"/>
-            </a:pPr>
-            <a:r>
-              <a:rPr lang="en-US" sz="1300" b="1" dirty="0">
-                <a:solidFill>
-                  <a:srgbClr val="1F4E79"/>
-                </a:solidFill>
-                <a:latin typeface="Arial" pitchFamily="34" charset="0"/>
-                <a:cs typeface="Arial" pitchFamily="34" charset="0"/>
-              </a:rPr>
-              <a:t>Technologies: </a:t>
-            </a:r>
-            <a:r>
-              <a:rPr lang="en-US" sz="1300" dirty="0">
-                <a:latin typeface="Arial" pitchFamily="34" charset="0"/>
-                <a:cs typeface="Arial" pitchFamily="34" charset="0"/>
-              </a:rPr>
-              <a:t>Python · PyTorch · HF Transformers · Qwen2.5-VL-7B + LoRA/PEFT (4-bit) · LangGraph agent · GDAL/rasterio · FastAPI backend · JS mission console · Docker (deployed: GitHub Pages + Render).</a:t>
-            </a:r>
-          </a:p>
-          <a:p>
-            <a:pPr marL="342900" indent="-342900" algn="just">
-              <a:buFont typeface="Arial" panose="020B0604020202020204" pitchFamily="34" charset="0"/>
-              <a:buChar char="•"/>
-            </a:pPr>
-            <a:r>
-              <a:rPr lang="en-US" sz="1300" b="1" dirty="0">
-                <a:solidFill>
-                  <a:srgbClr val="1F4E79"/>
-                </a:solidFill>
-                <a:latin typeface="Arial" pitchFamily="34" charset="0"/>
-                <a:cs typeface="Arial" pitchFamily="34" charset="0"/>
-              </a:rPr>
-              <a:t>Methodology: </a:t>
-            </a:r>
-            <a:r>
-              <a:rPr lang="en-US" sz="1300" dirty="0">
-                <a:latin typeface="Arial" pitchFamily="34" charset="0"/>
-                <a:cs typeface="Arial" pitchFamily="34" charset="0"/>
-              </a:rPr>
-              <a:t>Query → task classification → input validation (count/modality/CRS/co-registration) → specialist selection from registry → execution → evidence-grounded output + auditable trace:</a:t>
-            </a:r>
+            <a:endParaRPr lang="en-US"/>
           </a:p>
         </p:txBody>
       </p:sp>
@@ -6652,7 +6473,7 @@
       </p:pic>
       <p:pic>
         <p:nvPicPr>
-          <p:cNvPr id="17411" name="Architecture"/>
+          <p:cNvPr id="17411" name="Tech panel"/>
           <p:cNvPicPr>
             <a:picLocks noChangeAspect="1"/>
           </p:cNvPicPr>
@@ -6666,46 +6487,12 @@
         </p:blipFill>
         <p:spPr>
           <a:xfrm>
-            <a:off x="640080" y="3364992"/>
-            <a:ext cx="6949440" cy="3063240"/>
+            <a:off x="228600" y="1234440"/>
+            <a:ext cx="11731752" cy="5047488"/>
           </a:xfrm>
           <a:prstGeom prst="rect">
             <a:avLst/>
           </a:prstGeom>
-          <a:ln w="9525">
-            <a:solidFill>
-              <a:srgbClr val="1F4E79"/>
-            </a:solidFill>
-          </a:ln>
-        </p:spPr>
-      </p:pic>
-      <p:pic>
-        <p:nvPicPr>
-          <p:cNvPr id="17412" name="Demo QR"/>
-          <p:cNvPicPr>
-            <a:picLocks noChangeAspect="1"/>
-          </p:cNvPicPr>
-          <p:nvPr/>
-        </p:nvPicPr>
-        <p:blipFill>
-          <a:blip r:embed="rId5"/>
-          <a:stretch>
-            <a:fillRect/>
-          </a:stretch>
-        </p:blipFill>
-        <p:spPr>
-          <a:xfrm>
-            <a:off x="8001000" y="5138928"/>
-            <a:ext cx="1234440" cy="1234440"/>
-          </a:xfrm>
-          <a:prstGeom prst="rect">
-            <a:avLst/>
-          </a:prstGeom>
-          <a:ln w="9525">
-            <a:solidFill>
-              <a:srgbClr val="1F4E79"/>
-            </a:solidFill>
-          </a:ln>
         </p:spPr>
       </p:pic>
     </p:spTree>
@@ -6869,115 +6656,7 @@
           </a:bodyPr>
           <a:lstStyle/>
           <a:p>
-            <a:pPr marL="342900" indent="-342900" algn="just">
-              <a:buFont typeface="Arial" panose="020B0604020202020204" pitchFamily="34" charset="0"/>
-              <a:buChar char="•"/>
-            </a:pPr>
-            <a:r>
-              <a:rPr lang="en-US" sz="1400" b="1" dirty="0">
-                <a:solidFill>
-                  <a:srgbClr val="1F4E79"/>
-                </a:solidFill>
-                <a:latin typeface="Arial" pitchFamily="34" charset="0"/>
-                <a:cs typeface="Arial" pitchFamily="34" charset="0"/>
-              </a:rPr>
-              <a:t>Feasibility: </a:t>
-            </a:r>
-            <a:r>
-              <a:rPr lang="en-US" sz="1400" dirty="0">
-                <a:latin typeface="Arial" pitchFamily="34" charset="0"/>
-                <a:cs typeface="Arial" pitchFamily="34" charset="0"/>
-              </a:rPr>
-              <a:t>100% open datasets (BigEarthNet.txt, VRSBench, RSVQA, CDVQA); strong open RS baselines (GeoChat, RemoteCLIP); LoRA trains &lt;1% of parameters on a free T4 GPU; frontend + agentic FastAPI backend already deployed and public.</a:t>
-            </a:r>
-          </a:p>
-          <a:p>
-            <a:pPr marL="342900" indent="-342900" algn="just">
-              <a:buFont typeface="Arial" panose="020B0604020202020204" pitchFamily="34" charset="0"/>
-              <a:buChar char="•"/>
-            </a:pPr>
-            <a:r>
-              <a:rPr lang="en-US" sz="1400" b="1" dirty="0">
-                <a:solidFill>
-                  <a:srgbClr val="1F4E79"/>
-                </a:solidFill>
-                <a:latin typeface="Arial" pitchFamily="34" charset="0"/>
-                <a:cs typeface="Arial" pitchFamily="34" charset="0"/>
-              </a:rPr>
-              <a:t>Challenges &amp; risks: </a:t>
-            </a:r>
-            <a:r>
-              <a:rPr lang="en-US" sz="1400" dirty="0">
-                <a:latin typeface="Arial" pitchFamily="34" charset="0"/>
-                <a:cs typeface="Arial" pitchFamily="34" charset="0"/>
-              </a:rPr>
-              <a:t>Limited GPU compute · GeoTIFF/multi-band handling · domain gap to Cartosat-2S/RISAT evaluation data · VLM hallucination · orchestration failing live.</a:t>
-            </a:r>
-          </a:p>
-          <a:p>
-            <a:pPr marL="342900" indent="-342900" algn="just">
-              <a:buFont typeface="Arial" panose="020B0604020202020204" pitchFamily="34" charset="0"/>
-              <a:buChar char="•"/>
-            </a:pPr>
-            <a:r>
-              <a:rPr lang="en-US" sz="1400" dirty="0">
-                <a:latin typeface="Arial" pitchFamily="34" charset="0"/>
-                <a:cs typeface="Arial" pitchFamily="34" charset="0"/>
-              </a:rPr>
-              <a:t>Strategies to overcome:</a:t>
-            </a:r>
-          </a:p>
-          <a:p>
-            <a:pPr marL="742950" lvl="1" indent="-285750" algn="just">
-              <a:buFont typeface="Arial" panose="020B0604020202020204" pitchFamily="34" charset="0"/>
-              <a:buChar char="–"/>
-            </a:pPr>
-            <a:r>
-              <a:rPr lang="en-US" sz="1300" dirty="0">
-                <a:latin typeface="Arial" pitchFamily="34" charset="0"/>
-                <a:cs typeface="Arial" pitchFamily="34" charset="0"/>
-              </a:rPr>
-              <a:t>4-bit quantisation + LoRA adapters (compute); GDAL preprocessing — band selection, CRS checks, tiling (formats)</a:t>
-            </a:r>
-          </a:p>
-          <a:p>
-            <a:pPr marL="742950" lvl="1" indent="-285750" algn="just">
-              <a:buFont typeface="Arial" panose="020B0604020202020204" pitchFamily="34" charset="0"/>
-              <a:buChar char="–"/>
-            </a:pPr>
-            <a:r>
-              <a:rPr lang="en-US" sz="1300" dirty="0">
-                <a:latin typeface="Arial" pitchFamily="34" charset="0"/>
-                <a:cs typeface="Arial" pitchFamily="34" charset="0"/>
-              </a:rPr>
-              <a:t>Multisensor S1+S2 training + SAR-style speckle/resolution augmentation (domain transfer)</a:t>
-            </a:r>
-          </a:p>
-          <a:p>
-            <a:pPr marL="742950" lvl="1" indent="-285750" algn="just">
-              <a:buFont typeface="Arial" panose="020B0604020202020204" pitchFamily="34" charset="0"/>
-              <a:buChar char="–"/>
-            </a:pPr>
-            <a:r>
-              <a:rPr lang="en-US" sz="1300" dirty="0">
-                <a:latin typeface="Arial" pitchFamily="34" charset="0"/>
-                <a:cs typeface="Arial" pitchFamily="34" charset="0"/>
-              </a:rPr>
-              <a:t>Grounded outputs + confidence thresholds + strict input validator (hallucination)</a:t>
-            </a:r>
-          </a:p>
-          <a:p>
-            <a:pPr marL="742950" lvl="1" indent="-285750" algn="just">
-              <a:buFont typeface="Arial" panose="020B0604020202020204" pitchFamily="34" charset="0"/>
-              <a:buChar char="–"/>
-            </a:pPr>
-            <a:r>
-              <a:rPr lang="en-US" sz="1300" dirty="0">
-                <a:latin typeface="Arial" pitchFamily="34" charset="0"/>
-                <a:cs typeface="Arial" pitchFamily="34" charset="0"/>
-              </a:rPr>
-              <a:t>Deterministic routing + full execution trace + graceful fallback to single-image VQA (reliability)</a:t>
-            </a:r>
+            <a:endParaRPr lang="en-US"/>
           </a:p>
         </p:txBody>
       </p:sp>
@@ -7216,6 +6895,30 @@
           </a:prstGeom>
         </p:spPr>
       </p:pic>
+      <p:pic>
+        <p:nvPicPr>
+          <p:cNvPr id="17411" name="Feasibility panel"/>
+          <p:cNvPicPr>
+            <a:picLocks noChangeAspect="1"/>
+          </p:cNvPicPr>
+          <p:nvPr/>
+        </p:nvPicPr>
+        <p:blipFill>
+          <a:blip r:embed="rId4"/>
+          <a:stretch>
+            <a:fillRect/>
+          </a:stretch>
+        </p:blipFill>
+        <p:spPr>
+          <a:xfrm>
+            <a:off x="228600" y="1234440"/>
+            <a:ext cx="11731752" cy="5047488"/>
+          </a:xfrm>
+          <a:prstGeom prst="rect">
+            <a:avLst/>
+          </a:prstGeom>
+        </p:spPr>
+      </p:pic>
     </p:spTree>
     <p:extLst>
       <p:ext uri="{BB962C8B-B14F-4D97-AF65-F5344CB8AC3E}">
@@ -7382,119 +7085,7 @@
           </a:bodyPr>
           <a:lstStyle/>
           <a:p>
-            <a:pPr marL="342900" indent="-342900" algn="just">
-              <a:buFont typeface="Arial" panose="020B0604020202020204" pitchFamily="34" charset="0"/>
-              <a:buChar char="•"/>
-            </a:pPr>
-            <a:r>
-              <a:rPr lang="en-US" sz="1400" b="1" dirty="0">
-                <a:solidFill>
-                  <a:srgbClr val="1F4E79"/>
-                </a:solidFill>
-                <a:latin typeface="Arial" pitchFamily="34" charset="0"/>
-                <a:cs typeface="Arial" pitchFamily="34" charset="0"/>
-              </a:rPr>
-              <a:t>Target audience: </a:t>
-            </a:r>
-            <a:r>
-              <a:rPr lang="en-US" sz="1400" dirty="0">
-                <a:latin typeface="Arial" pitchFamily="34" charset="0"/>
-                <a:cs typeface="Arial" pitchFamily="34" charset="0"/>
-              </a:rPr>
-              <a:t>District officials, disaster-response teams, planners, farmers’ bodies and NGOs can question satellite imagery in plain language — no GIS training required.</a:t>
-            </a:r>
-          </a:p>
-          <a:p>
-            <a:pPr marL="342900" indent="-342900" algn="just">
-              <a:buFont typeface="Arial" panose="020B0604020202020204" pitchFamily="34" charset="0"/>
-              <a:buChar char="•"/>
-            </a:pPr>
-            <a:r>
-              <a:rPr lang="en-US" sz="1400" b="1" dirty="0">
-                <a:solidFill>
-                  <a:srgbClr val="1F4E79"/>
-                </a:solidFill>
-                <a:latin typeface="Arial" pitchFamily="34" charset="0"/>
-                <a:cs typeface="Arial" pitchFamily="34" charset="0"/>
-              </a:rPr>
-              <a:t>Social: </a:t>
-            </a:r>
-            <a:r>
-              <a:rPr lang="en-US" sz="1400" dirty="0">
-                <a:latin typeface="Arial" pitchFamily="34" charset="0"/>
-                <a:cs typeface="Arial" pitchFamily="34" charset="0"/>
-              </a:rPr>
-              <a:t>Democratises ISRO Earth-observation data for non-experts across governance and civil society.</a:t>
-            </a:r>
-          </a:p>
-          <a:p>
-            <a:pPr marL="342900" indent="-342900" algn="just">
-              <a:buFont typeface="Arial" panose="020B0604020202020204" pitchFamily="34" charset="0"/>
-              <a:buChar char="•"/>
-            </a:pPr>
-            <a:r>
-              <a:rPr lang="en-US" sz="1400" b="1" dirty="0">
-                <a:solidFill>
-                  <a:srgbClr val="1F4E79"/>
-                </a:solidFill>
-                <a:latin typeface="Arial" pitchFamily="34" charset="0"/>
-                <a:cs typeface="Arial" pitchFamily="34" charset="0"/>
-              </a:rPr>
-              <a:t>Economic: </a:t>
-            </a:r>
-            <a:r>
-              <a:rPr lang="en-US" sz="1400" dirty="0">
-                <a:latin typeface="Arial" pitchFamily="34" charset="0"/>
-                <a:cs typeface="Arial" pitchFamily="34" charset="0"/>
-              </a:rPr>
-              <a:t>Hours of manual multi-tool GIS analysis reduced to seconds per query; one platform replaces many single-task systems.</a:t>
-            </a:r>
-          </a:p>
-          <a:p>
-            <a:pPr marL="342900" indent="-342900" algn="just">
-              <a:buFont typeface="Arial" panose="020B0604020202020204" pitchFamily="34" charset="0"/>
-              <a:buChar char="•"/>
-            </a:pPr>
-            <a:r>
-              <a:rPr lang="en-US" sz="1400" b="1" dirty="0">
-                <a:solidFill>
-                  <a:srgbClr val="1F4E79"/>
-                </a:solidFill>
-                <a:latin typeface="Arial" pitchFamily="34" charset="0"/>
-                <a:cs typeface="Arial" pitchFamily="34" charset="0"/>
-              </a:rPr>
-              <a:t>Environmental: </a:t>
-            </a:r>
-            <a:r>
-              <a:rPr lang="en-US" sz="1400" dirty="0">
-                <a:latin typeface="Arial" pitchFamily="34" charset="0"/>
-                <a:cs typeface="Arial" pitchFamily="34" charset="0"/>
-              </a:rPr>
-              <a:t>Continuous monitoring of forests, water bodies, cropland and urban sprawl; SAR works through clouds, day and night — critical for floods and cyclones.</a:t>
-            </a:r>
-          </a:p>
-          <a:p>
-            <a:pPr marL="342900" indent="-342900" algn="just">
-              <a:buFont typeface="Arial" panose="020B0604020202020204" pitchFamily="34" charset="0"/>
-              <a:buChar char="•"/>
-            </a:pPr>
-            <a:r>
-              <a:rPr lang="en-US" sz="1400" b="1" dirty="0">
-                <a:solidFill>
-                  <a:srgbClr val="1F4E79"/>
-                </a:solidFill>
-                <a:latin typeface="Arial" pitchFamily="34" charset="0"/>
-                <a:cs typeface="Arial" pitchFamily="34" charset="0"/>
-              </a:rPr>
-              <a:t>Strategic: </a:t>
-            </a:r>
-            <a:r>
-              <a:rPr lang="en-US" sz="1400" dirty="0">
-                <a:latin typeface="Arial" pitchFamily="34" charset="0"/>
-                <a:cs typeface="Arial" pitchFamily="34" charset="0"/>
-              </a:rPr>
-              <a:t>Multiplies the value of Cartosat &amp; RISAT missions; auditable, evidence-grounded AI suitable for official use.</a:t>
-            </a:r>
+            <a:endParaRPr lang="en-US"/>
           </a:p>
         </p:txBody>
       </p:sp>
@@ -7733,6 +7324,30 @@
           </a:prstGeom>
         </p:spPr>
       </p:pic>
+      <p:pic>
+        <p:nvPicPr>
+          <p:cNvPr id="17411" name="Impact panel"/>
+          <p:cNvPicPr>
+            <a:picLocks noChangeAspect="1"/>
+          </p:cNvPicPr>
+          <p:nvPr/>
+        </p:nvPicPr>
+        <p:blipFill>
+          <a:blip r:embed="rId4"/>
+          <a:stretch>
+            <a:fillRect/>
+          </a:stretch>
+        </p:blipFill>
+        <p:spPr>
+          <a:xfrm>
+            <a:off x="228600" y="1234440"/>
+            <a:ext cx="11731752" cy="5047488"/>
+          </a:xfrm>
+          <a:prstGeom prst="rect">
+            <a:avLst/>
+          </a:prstGeom>
+        </p:spPr>
+      </p:pic>
     </p:spTree>
     <p:extLst>
       <p:ext uri="{BB962C8B-B14F-4D97-AF65-F5344CB8AC3E}">
@@ -7899,109 +7514,7 @@
           </a:bodyPr>
           <a:lstStyle/>
           <a:p>
-            <a:pPr marL="342900" indent="-342900" algn="just">
-              <a:buFont typeface="Arial" panose="020B0604020202020204" pitchFamily="34" charset="0"/>
-              <a:buChar char="•"/>
-            </a:pPr>
-            <a:r>
-              <a:rPr lang="en-US" sz="1400" b="1" dirty="0">
-                <a:solidFill>
-                  <a:srgbClr val="C00000"/>
-                </a:solidFill>
-                <a:latin typeface="Arial" pitchFamily="34" charset="0"/>
-                <a:cs typeface="Arial" pitchFamily="34" charset="0"/>
-              </a:rPr>
-              <a:t>Live prototype: </a:t>
-            </a:r>
-            <a:r>
-              <a:rPr lang="en-US" sz="1400" dirty="0">
-                <a:latin typeface="Arial" pitchFamily="34" charset="0"/>
-                <a:cs typeface="Arial" pitchFamily="34" charset="0"/>
-              </a:rPr>
-              <a:t>gangadhar017.github.io/Lunar_circle · Source + backend: github.com/Gangadhar017/Lunar_circle</a:t>
-            </a:r>
-          </a:p>
-          <a:p>
-            <a:pPr marL="342900" indent="-342900" algn="just">
-              <a:buFont typeface="Arial" panose="020B0604020202020204" pitchFamily="34" charset="0"/>
-              <a:buChar char="•"/>
-            </a:pPr>
-            <a:r>
-              <a:rPr lang="en-US" sz="1400" b="1" dirty="0">
-                <a:solidFill>
-                  <a:srgbClr val="1F4E79"/>
-                </a:solidFill>
-                <a:latin typeface="Arial" pitchFamily="34" charset="0"/>
-                <a:cs typeface="Arial" pitchFamily="34" charset="0"/>
-              </a:rPr>
-              <a:t>Training dataset: </a:t>
-            </a:r>
-            <a:r>
-              <a:rPr lang="en-US" sz="1400" dirty="0">
-                <a:latin typeface="Arial" pitchFamily="34" charset="0"/>
-                <a:cs typeface="Arial" pitchFamily="34" charset="0"/>
-              </a:rPr>
-              <a:t>BigEarthNet.txt — arXiv:2603.29630 · txt.bigearth.net (464,044 co-registered S1+S2 pairs, 9.6M annotations; captions, VQA, referring-expression detection)</a:t>
-            </a:r>
-          </a:p>
-          <a:p>
-            <a:pPr marL="342900" indent="-342900" algn="just">
-              <a:buFont typeface="Arial" panose="020B0604020202020204" pitchFamily="34" charset="0"/>
-              <a:buChar char="•"/>
-            </a:pPr>
-            <a:r>
-              <a:rPr lang="en-US" sz="1400" b="1" dirty="0">
-                <a:solidFill>
-                  <a:srgbClr val="1F4E79"/>
-                </a:solidFill>
-                <a:latin typeface="Arial" pitchFamily="34" charset="0"/>
-                <a:cs typeface="Arial" pitchFamily="34" charset="0"/>
-              </a:rPr>
-              <a:t>Evaluation benchmarks: </a:t>
-            </a:r>
-            <a:r>
-              <a:rPr lang="en-US" sz="1400" dirty="0">
-                <a:latin typeface="Arial" pitchFamily="34" charset="0"/>
-                <a:cs typeface="Arial" pitchFamily="34" charset="0"/>
-              </a:rPr>
-              <a:t>VRSBench — github.com/lx709/VRSBench · RSVQA — rsvqa.sylvainlobry.com · CDVQA — github.com/YZHJessica/CDVQA</a:t>
-            </a:r>
-          </a:p>
-          <a:p>
-            <a:pPr marL="342900" indent="-342900" algn="just">
-              <a:buFont typeface="Arial" panose="020B0604020202020204" pitchFamily="34" charset="0"/>
-              <a:buChar char="•"/>
-            </a:pPr>
-            <a:r>
-              <a:rPr lang="en-US" sz="1400" b="1" dirty="0">
-                <a:solidFill>
-                  <a:srgbClr val="1F4E79"/>
-                </a:solidFill>
-                <a:latin typeface="Arial" pitchFamily="34" charset="0"/>
-                <a:cs typeface="Arial" pitchFamily="34" charset="0"/>
-              </a:rPr>
-              <a:t>Key research: </a:t>
-            </a:r>
-            <a:r>
-              <a:rPr lang="en-US" sz="1400" dirty="0">
-                <a:latin typeface="Arial" pitchFamily="34" charset="0"/>
-                <a:cs typeface="Arial" pitchFamily="34" charset="0"/>
-              </a:rPr>
-              <a:t>GeoChat (CVPR 2024) · RemoteCLIP (2024) · RSVQA (IEEE TGRS 2020) · CDVQA (IEEE TGRS 2022) · LoRA (ICLR 2022)</a:t>
-            </a:r>
-          </a:p>
-          <a:p>
-            <a:pPr marL="342900" indent="-342900" algn="just">
-              <a:buFont typeface="Arial" panose="020B0604020202020204" pitchFamily="34" charset="0"/>
-              <a:buChar char="•"/>
-            </a:pPr>
-            <a:r>
-              <a:rPr lang="en-US" sz="1400" dirty="0">
-                <a:latin typeface="Arial" pitchFamily="34" charset="0"/>
-                <a:cs typeface="Arial" pitchFamily="34" charset="0"/>
-              </a:rPr>
-              <a:t>Final evaluation readiness: prescribed public test splits with normalised scores; multisensor training targets the ISRO/SAC Cartosat-2S + RISAT hidden set.</a:t>
-            </a:r>
+            <a:endParaRPr lang="en-US"/>
           </a:p>
         </p:txBody>
       </p:sp>
@@ -8242,7 +7755,7 @@
       </p:pic>
       <p:pic>
         <p:nvPicPr>
-          <p:cNvPr id="17411" name="Demo QR"/>
+          <p:cNvPr id="17411" name="References panel"/>
           <p:cNvPicPr>
             <a:picLocks noChangeAspect="1"/>
           </p:cNvPicPr>
@@ -8256,17 +7769,12 @@
         </p:blipFill>
         <p:spPr>
           <a:xfrm>
-            <a:off x="10561320" y="5029200"/>
-            <a:ext cx="1143000" cy="1143000"/>
+            <a:off x="228600" y="1234440"/>
+            <a:ext cx="11731752" cy="5047488"/>
           </a:xfrm>
           <a:prstGeom prst="rect">
             <a:avLst/>
           </a:prstGeom>
-          <a:ln w="9525">
-            <a:solidFill>
-              <a:srgbClr val="1F4E79"/>
-            </a:solidFill>
-          </a:ln>
         </p:spPr>
       </p:pic>
     </p:spTree>

</xml_diff>